<commit_message>
Add emergency call buttons, rename tab to Help, update deck
</commit_message>
<xml_diff>
--- a/brasil-seguro.pptx
+++ b/brasil-seguro.pptx
@@ -2115,7 +2115,7 @@
                   <a:srgbClr val="5D6673"/>
                 </a:solidFill>
               </a:rPr>
-              <a:t>Proposta de serviço público · Governo Federal · simulação acadêmica</a:t>
+              <a:t>Proposta de serviço público</a:t>
             </a:r>
             <a:endParaRPr lang="en-US" sz="1050" dirty="0"/>
           </a:p>
@@ -2747,7 +2747,7 @@
                   <a:srgbClr val="9FB3D1"/>
                 </a:solidFill>
               </a:rPr>
-              <a:t>PROPOSTA DE SERVIÇO PÚBLICO DIGITAL · GOVERNO FEDERAL</a:t>
+              <a:t>PROPOSTA DE SERVIÇO PÚBLICO DIGITAL</a:t>
             </a:r>
             <a:endParaRPr lang="en-US" sz="1300" dirty="0"/>
           </a:p>
@@ -8262,7 +8262,7 @@
                   <a:srgbClr val="9FB3D1"/>
                 </a:solidFill>
               </a:rPr>
-              <a:t>UNIRIO · Proposta de serviço público para o Governo Federal (simulação acadêmica)</a:t>
+              <a:t>UNIRIO · Proposta de serviço público</a:t>
             </a:r>
             <a:endParaRPr lang="en-US" sz="1500" dirty="0"/>
           </a:p>

</xml_diff>

<commit_message>
Remove cover tag from deck
</commit_message>
<xml_diff>
--- a/brasil-seguro.pptx
+++ b/brasil-seguro.pptx
@@ -3008,70 +3008,7 @@
       </p:sp>
       <p:sp>
         <p:nvSpPr>
-          <p:cNvPr id="6" name="Shape 3"/>
-          <p:cNvSpPr/>
-          <p:nvPr/>
-        </p:nvSpPr>
-        <p:spPr>
-          <a:xfrm>
-            <a:off x="731520" y="1417320"/>
-            <a:ext cx="2148840" cy="347472"/>
-          </a:xfrm>
-          <a:prstGeom prst="roundRect">
-            <a:avLst>
-              <a:gd name="adj" fmla="val 50000"/>
-            </a:avLst>
-          </a:prstGeom>
-          <a:solidFill>
-            <a:srgbClr val="168821"/>
-          </a:solidFill>
-          <a:ln w="12700">
-            <a:solidFill>
-              <a:srgbClr val="168821"/>
-            </a:solidFill>
-            <a:prstDash val="solid"/>
-          </a:ln>
-        </p:spPr>
-      </p:sp>
-      <p:sp>
-        <p:nvSpPr>
-          <p:cNvPr id="7" name="Text 4"/>
-          <p:cNvSpPr txBox="1"/>
-          <p:nvPr/>
-        </p:nvSpPr>
-        <p:spPr>
-          <a:xfrm>
-            <a:off x="731520" y="1417320"/>
-            <a:ext cx="2148840" cy="347472"/>
-          </a:xfrm>
-          <a:prstGeom prst="rect">
-            <a:avLst/>
-          </a:prstGeom>
-          <a:noFill/>
-          <a:ln/>
-        </p:spPr>
-        <p:txBody>
-          <a:bodyPr wrap="square" lIns="0" tIns="0" rIns="0" bIns="0" rtlCol="0" anchor="ctr"/>
-          <a:lstStyle/>
-          <a:p>
-            <a:pPr algn="ctr" indent="0" marL="0">
-              <a:buNone/>
-            </a:pPr>
-            <a:r>
-              <a:rPr lang="en-US" sz="1100" b="1" spc="200" kern="0" dirty="0">
-                <a:solidFill>
-                  <a:srgbClr val="FFFFFF"/>
-                </a:solidFill>
-              </a:rPr>
-              <a:t>INOVAÇÃO SOCIAL</a:t>
-            </a:r>
-            <a:endParaRPr lang="en-US" sz="1100" dirty="0"/>
-          </a:p>
-        </p:txBody>
-      </p:sp>
-      <p:sp>
-        <p:nvSpPr>
-          <p:cNvPr id="8" name="Text 5"/>
+          <p:cNvPr id="6" name="Text 3"/>
           <p:cNvSpPr txBox="1"/>
           <p:nvPr/>
         </p:nvSpPr>
@@ -3107,7 +3044,7 @@
       </p:sp>
       <p:sp>
         <p:nvSpPr>
-          <p:cNvPr id="9" name="Text 6"/>
+          <p:cNvPr id="7" name="Text 4"/>
           <p:cNvSpPr txBox="1"/>
           <p:nvPr/>
         </p:nvSpPr>
@@ -3157,7 +3094,7 @@
       </p:sp>
       <p:sp>
         <p:nvSpPr>
-          <p:cNvPr id="10" name="Shape 7"/>
+          <p:cNvPr id="8" name="Shape 5"/>
           <p:cNvSpPr/>
           <p:nvPr/>
         </p:nvSpPr>
@@ -3184,7 +3121,7 @@
       </p:sp>
       <p:pic>
         <p:nvPicPr>
-          <p:cNvPr id="11" name="Image 1" descr="qr-urca.png">    </p:cNvPr>
+          <p:cNvPr id="9" name="Image 1" descr="qr-urca.png">    </p:cNvPr>
           <p:cNvPicPr>
             <a:picLocks noChangeAspect="1"/>
           </p:cNvPicPr>
@@ -3208,7 +3145,7 @@
       </p:pic>
       <p:sp>
         <p:nvSpPr>
-          <p:cNvPr id="12" name="Text 8"/>
+          <p:cNvPr id="10" name="Text 6"/>
           <p:cNvSpPr txBox="1"/>
           <p:nvPr/>
         </p:nvSpPr>
@@ -3244,7 +3181,7 @@
       </p:sp>
       <p:sp>
         <p:nvSpPr>
-          <p:cNvPr id="13" name="Text 9"/>
+          <p:cNvPr id="11" name="Text 7"/>
           <p:cNvSpPr txBox="1"/>
           <p:nvPr/>
         </p:nvSpPr>

</xml_diff>